<commit_message>
Add NGBoost as the new (untaught) algorithm with 80% price ranges; correct CatBoost as a taught model
New 05_ngboost.ipynb (tuning, calibration, SHAP), price range in the app, NGBoost in the retraining pipeline and quality gate, 17 tests, report/slides/scripts updated. pandas pinned to 2.3.3 because NGBoost's dependency lifelines needs pandas < 3.
</commit_message>
<xml_diff>
--- a/Presentation.pptx
+++ b/Presentation.pptx
@@ -116,7 +116,7 @@
   <p:extLst>
     <p:ext uri="{521415D9-36F7-43E2-AB2F-B90AF26B5E84}">
       <p14:sectionLst xmlns:p14="http://schemas.microsoft.com/office/powerpoint/2010/main">
-        <p14:section name="Presentation" id="{ef46170f-05f3-2198-ebb9-680a9c5244fc}">
+        <p14:section name="Presentation" id="{7ccc21e6-e0ec-8f38-8191-e0095dd1da7d}">
           <p14:sldIdLst>
             <p14:sldId id="256"/>
             <p14:sldId id="257"/>
@@ -128,7 +128,7 @@
             <p14:sldId id="263"/>
           </p14:sldIdLst>
         </p14:section>
-        <p14:section name="Appendix" id="{a1d11ab2-0ef6-a90e-c393-fcc0477535a3}">
+        <p14:section name="Appendix" id="{6154ce8b-ce1f-0012-6ab7-6099dce4b4a4}">
           <p14:sldIdLst>
             <p14:sldId id="264"/>
             <p14:sldId id="265"/>
@@ -1542,7 +1542,7 @@
           <a:p>
             <a:r>
               <a:rPr lang="en-US" dirty="0"/>
-              <a:t>[0:55] This table compares every model I trained. Random Forest and XGBoost were taught in the module, so together with a Ridge baseline they are my comparison models. My new algorithm is CatBoost, which was not covered in the lectures. I chose it because the area column has 160 categories, many of them rare, and CatBoost encodes categories without leaking the target. It reached an R-squared of 0.866, tied for best, and it generalised best to areas it had never seen. Tuning with five-fold cross-validation clearly helped: about 0.83 with default settings, 0.86 tuned. The final model is a stacking ensemble of Random Forest, XGBoost and CatBoost, chosen because it had the lowest cross-validated error. It reaches a median error of about 12 percent.</a:t>
+              <a:t>[0:55] This table compares every model I trained. Ridge, Random Forest, XGBoost, LightGBM, CatBoost and stacking were all taught in the module. My new algorithm is NGBoost, which was not covered in the lectures. Every taught model predicts one number; NGBoost predicts a whole probability distribution of the price, using natural gradient boosting, so it can give a price range. After tuning with five-fold cross-validation it ranks third of eight, with an R-squared of 0.863, and its 80 percent ranges contain 82 percent of actual prices. Tuning helped every model: about 0.83 with default settings, 0.86 tuned. The final price model is the stacking ensemble, which had the lowest cross-validated error and a median error of about 12 percent.</a:t>
             </a:r>
             <a:endParaRPr lang="en-US" dirty="0"/>
           </a:p>
@@ -1806,7 +1806,7 @@
           <a:p>
             <a:r>
               <a:rPr lang="en-US" dirty="0"/>
-              <a:t>[0:45] Here is the deployed application. [Switch to the browser.] I choose an area and a size. Battaramulla, about 11 kilometres from Fort, comes out at about 2.6 million rupees per perch, in the high band; Kaduwela, further out, at about 460,000, in the low band. Under each price, the app explains it: for Battaramulla, its location roughly doubles the price compared with a typical plot. Behind it is a GitHub repository with 15 automated tests, a retraining pipeline with a quality gate, and automatic redeployment. [Switch back to the slides.]</a:t>
+              <a:t>[0:45] Here is the deployed application. [Switch to the browser.] I choose an area and a size. Battaramulla, about 11 kilometres from Fort, comes out at about 2.6 million rupees per perch, in the high band; Kaduwela, further out, at about 460,000, in the low band. Under each price, NGBoost gives a likely range, for Battaramulla about 1.5 to 4 million, and SHAP explains it: Battaramulla's location roughly doubles the price compared with a typical plot. Behind it is a GitHub repository with 17 automated tests, a retraining pipeline with a quality gate, and automatic redeployment. [Switch back to the slides.]</a:t>
             </a:r>
             <a:endParaRPr lang="en-US" dirty="0"/>
           </a:p>
@@ -3048,7 +3048,7 @@
                 <a:gridCol w="4846320"/>
                 <a:gridCol w="4389120"/>
               </a:tblGrid>
-              <a:tr h="777240">
+              <a:tr h="713232">
                 <a:tc>
                   <a:txBody>
                     <a:bodyPr/>
@@ -3233,7 +3233,7 @@
                   </a:tcPr>
                 </a:tc>
               </a:tr>
-              <a:tr h="777240">
+              <a:tr h="713232">
                 <a:tc>
                   <a:txBody>
                     <a:bodyPr/>
@@ -3409,7 +3409,7 @@
                   </a:tcPr>
                 </a:tc>
               </a:tr>
-              <a:tr h="777240">
+              <a:tr h="713232">
                 <a:tc>
                   <a:txBody>
                     <a:bodyPr/>
@@ -3585,7 +3585,7 @@
                   </a:tcPr>
                 </a:tc>
               </a:tr>
-              <a:tr h="777240">
+              <a:tr h="713232">
                 <a:tc>
                   <a:txBody>
                     <a:bodyPr/>
@@ -3761,7 +3761,7 @@
                   </a:tcPr>
                 </a:tc>
               </a:tr>
-              <a:tr h="777240">
+              <a:tr h="713232">
                 <a:tc>
                   <a:txBody>
                     <a:bodyPr/>
@@ -3893,6 +3893,182 @@
                           </a:solidFill>
                         </a:rPr>
                         <a:t>Native handling of the 160-area category</a:t>
+                      </a:r>
+                      <a:endParaRPr lang="en-US" sz="1400" dirty="0"/>
+                    </a:p>
+                  </a:txBody>
+                  <a:tcPr marL="91440" marR="91440" marT="45720" marB="45720" anchor="ctr">
+                    <a:lnL w="9525" cap="flat" cmpd="sng" algn="ctr">
+                      <a:solidFill>
+                        <a:srgbClr val="E2E6EB"/>
+                      </a:solidFill>
+                      <a:prstDash val="solid"/>
+                      <a:round/>
+                      <a:headEnd type="none" w="med" len="med"/>
+                      <a:tailEnd type="none" w="med" len="med"/>
+                    </a:lnL>
+                    <a:lnR w="9525" cap="flat" cmpd="sng" algn="ctr">
+                      <a:solidFill>
+                        <a:srgbClr val="E2E6EB"/>
+                      </a:solidFill>
+                      <a:prstDash val="solid"/>
+                      <a:round/>
+                      <a:headEnd type="none" w="med" len="med"/>
+                      <a:tailEnd type="none" w="med" len="med"/>
+                    </a:lnR>
+                    <a:lnT w="9525" cap="flat" cmpd="sng" algn="ctr">
+                      <a:solidFill>
+                        <a:srgbClr val="E2E6EB"/>
+                      </a:solidFill>
+                      <a:prstDash val="solid"/>
+                      <a:round/>
+                      <a:headEnd type="none" w="med" len="med"/>
+                      <a:tailEnd type="none" w="med" len="med"/>
+                    </a:lnT>
+                    <a:lnB w="9525" cap="flat" cmpd="sng" algn="ctr">
+                      <a:solidFill>
+                        <a:srgbClr val="E2E6EB"/>
+                      </a:solidFill>
+                      <a:prstDash val="solid"/>
+                      <a:round/>
+                      <a:headEnd type="none" w="med" len="med"/>
+                      <a:tailEnd type="none" w="med" len="med"/>
+                    </a:lnB>
+                  </a:tcPr>
+                </a:tc>
+              </a:tr>
+              <a:tr h="713232">
+                <a:tc>
+                  <a:txBody>
+                    <a:bodyPr/>
+                    <a:lstStyle/>
+                    <a:p>
+                      <a:pPr indent="0" marL="0">
+                        <a:buNone/>
+                      </a:pPr>
+                      <a:r>
+                        <a:rPr lang="en-US" sz="1400" dirty="0">
+                          <a:solidFill>
+                            <a:srgbClr val="1C2430"/>
+                          </a:solidFill>
+                        </a:rPr>
+                        <a:t>NGBoost ★</a:t>
+                      </a:r>
+                      <a:endParaRPr lang="en-US" sz="1400" dirty="0"/>
+                    </a:p>
+                  </a:txBody>
+                  <a:tcPr marL="91440" marR="91440" marT="45720" marB="45720" anchor="ctr">
+                    <a:lnL w="9525" cap="flat" cmpd="sng" algn="ctr">
+                      <a:solidFill>
+                        <a:srgbClr val="E2E6EB"/>
+                      </a:solidFill>
+                      <a:prstDash val="solid"/>
+                      <a:round/>
+                      <a:headEnd type="none" w="med" len="med"/>
+                      <a:tailEnd type="none" w="med" len="med"/>
+                    </a:lnL>
+                    <a:lnR w="9525" cap="flat" cmpd="sng" algn="ctr">
+                      <a:solidFill>
+                        <a:srgbClr val="E2E6EB"/>
+                      </a:solidFill>
+                      <a:prstDash val="solid"/>
+                      <a:round/>
+                      <a:headEnd type="none" w="med" len="med"/>
+                      <a:tailEnd type="none" w="med" len="med"/>
+                    </a:lnR>
+                    <a:lnT w="9525" cap="flat" cmpd="sng" algn="ctr">
+                      <a:solidFill>
+                        <a:srgbClr val="E2E6EB"/>
+                      </a:solidFill>
+                      <a:prstDash val="solid"/>
+                      <a:round/>
+                      <a:headEnd type="none" w="med" len="med"/>
+                      <a:tailEnd type="none" w="med" len="med"/>
+                    </a:lnT>
+                    <a:lnB w="9525" cap="flat" cmpd="sng" algn="ctr">
+                      <a:solidFill>
+                        <a:srgbClr val="E2E6EB"/>
+                      </a:solidFill>
+                      <a:prstDash val="solid"/>
+                      <a:round/>
+                      <a:headEnd type="none" w="med" len="med"/>
+                      <a:tailEnd type="none" w="med" len="med"/>
+                    </a:lnB>
+                  </a:tcPr>
+                </a:tc>
+                <a:tc>
+                  <a:txBody>
+                    <a:bodyPr/>
+                    <a:lstStyle/>
+                    <a:p>
+                      <a:pPr indent="0" marL="0">
+                        <a:buNone/>
+                      </a:pPr>
+                      <a:r>
+                        <a:rPr lang="en-US" sz="1400" dirty="0">
+                          <a:solidFill>
+                            <a:srgbClr val="1C2430"/>
+                          </a:solidFill>
+                        </a:rPr>
+                        <a:t>489 iterations, learning_rate 0.0076, base trees depth 5, min 15 per leaf</a:t>
+                      </a:r>
+                      <a:endParaRPr lang="en-US" sz="1400" dirty="0"/>
+                    </a:p>
+                  </a:txBody>
+                  <a:tcPr marL="91440" marR="91440" marT="45720" marB="45720" anchor="ctr">
+                    <a:lnL w="9525" cap="flat" cmpd="sng" algn="ctr">
+                      <a:solidFill>
+                        <a:srgbClr val="E2E6EB"/>
+                      </a:solidFill>
+                      <a:prstDash val="solid"/>
+                      <a:round/>
+                      <a:headEnd type="none" w="med" len="med"/>
+                      <a:tailEnd type="none" w="med" len="med"/>
+                    </a:lnL>
+                    <a:lnR w="9525" cap="flat" cmpd="sng" algn="ctr">
+                      <a:solidFill>
+                        <a:srgbClr val="E2E6EB"/>
+                      </a:solidFill>
+                      <a:prstDash val="solid"/>
+                      <a:round/>
+                      <a:headEnd type="none" w="med" len="med"/>
+                      <a:tailEnd type="none" w="med" len="med"/>
+                    </a:lnR>
+                    <a:lnT w="9525" cap="flat" cmpd="sng" algn="ctr">
+                      <a:solidFill>
+                        <a:srgbClr val="E2E6EB"/>
+                      </a:solidFill>
+                      <a:prstDash val="solid"/>
+                      <a:round/>
+                      <a:headEnd type="none" w="med" len="med"/>
+                      <a:tailEnd type="none" w="med" len="med"/>
+                    </a:lnT>
+                    <a:lnB w="9525" cap="flat" cmpd="sng" algn="ctr">
+                      <a:solidFill>
+                        <a:srgbClr val="E2E6EB"/>
+                      </a:solidFill>
+                      <a:prstDash val="solid"/>
+                      <a:round/>
+                      <a:headEnd type="none" w="med" len="med"/>
+                      <a:tailEnd type="none" w="med" len="med"/>
+                    </a:lnB>
+                  </a:tcPr>
+                </a:tc>
+                <a:tc>
+                  <a:txBody>
+                    <a:bodyPr/>
+                    <a:lstStyle/>
+                    <a:p>
+                      <a:pPr indent="0" marL="0">
+                        <a:buNone/>
+                      </a:pPr>
+                      <a:r>
+                        <a:rPr lang="en-US" sz="1400" dirty="0">
+                          <a:solidFill>
+                            <a:srgbClr val="1C2430"/>
+                          </a:solidFill>
+                        </a:rPr>
+                        <a:t>Small steps; larger leaves stop the spread fitting single noisy listings</a:t>
                       </a:r>
                       <a:endParaRPr lang="en-US" sz="1400" dirty="0"/>
                     </a:p>
@@ -5237,7 +5413,7 @@
                   <a:schemeClr val="tx2"/>
                 </a:solidFill>
               </a:rPr>
-              <a:t>Model accuracy: CatBoost (new) and the final stack</a:t>
+              <a:t>Model accuracy: NGBoost (new) and the final stack</a:t>
             </a:r>
             <a:endParaRPr lang="en-US" sz="3200" dirty="0"/>
           </a:p>
@@ -5271,7 +5447,7 @@
                 <a:gridCol w="1280160"/>
                 <a:gridCol w="1554480"/>
               </a:tblGrid>
-              <a:tr h="457200">
+              <a:tr h="411480">
                 <a:tc>
                   <a:txBody>
                     <a:bodyPr/>
@@ -5517,7 +5693,7 @@
                   </a:tcPr>
                 </a:tc>
               </a:tr>
-              <a:tr h="457200">
+              <a:tr h="411480">
                 <a:tc>
                   <a:txBody>
                     <a:bodyPr/>
@@ -5763,7 +5939,7 @@
                   </a:tcPr>
                 </a:tc>
               </a:tr>
-              <a:tr h="457200">
+              <a:tr h="411480">
                 <a:tc>
                   <a:txBody>
                     <a:bodyPr/>
@@ -6009,7 +6185,253 @@
                   </a:tcPr>
                 </a:tc>
               </a:tr>
-              <a:tr h="457200">
+              <a:tr h="411480">
+                <a:tc>
+                  <a:txBody>
+                    <a:bodyPr/>
+                    <a:lstStyle/>
+                    <a:p>
+                      <a:pPr algn="l" indent="0" marL="0">
+                        <a:buNone/>
+                      </a:pPr>
+                      <a:r>
+                        <a:rPr lang="en-US" sz="1500" b="1" dirty="0">
+                          <a:solidFill>
+                            <a:srgbClr val="1F4E79"/>
+                          </a:solidFill>
+                        </a:rPr>
+                        <a:t>NGBoost (tuned) ★ new</a:t>
+                      </a:r>
+                      <a:endParaRPr lang="en-US" sz="1500" dirty="0"/>
+                    </a:p>
+                  </a:txBody>
+                  <a:tcPr marL="91440" marR="91440" marT="45720" marB="45720" anchor="ctr">
+                    <a:lnL w="9525" cap="flat" cmpd="sng" algn="ctr">
+                      <a:solidFill>
+                        <a:srgbClr val="E2E6EB"/>
+                      </a:solidFill>
+                      <a:prstDash val="solid"/>
+                      <a:round/>
+                      <a:headEnd type="none" w="med" len="med"/>
+                      <a:tailEnd type="none" w="med" len="med"/>
+                    </a:lnL>
+                    <a:lnR w="9525" cap="flat" cmpd="sng" algn="ctr">
+                      <a:solidFill>
+                        <a:srgbClr val="E2E6EB"/>
+                      </a:solidFill>
+                      <a:prstDash val="solid"/>
+                      <a:round/>
+                      <a:headEnd type="none" w="med" len="med"/>
+                      <a:tailEnd type="none" w="med" len="med"/>
+                    </a:lnR>
+                    <a:lnT w="9525" cap="flat" cmpd="sng" algn="ctr">
+                      <a:solidFill>
+                        <a:srgbClr val="E2E6EB"/>
+                      </a:solidFill>
+                      <a:prstDash val="solid"/>
+                      <a:round/>
+                      <a:headEnd type="none" w="med" len="med"/>
+                      <a:tailEnd type="none" w="med" len="med"/>
+                    </a:lnT>
+                    <a:lnB w="9525" cap="flat" cmpd="sng" algn="ctr">
+                      <a:solidFill>
+                        <a:srgbClr val="E2E6EB"/>
+                      </a:solidFill>
+                      <a:prstDash val="solid"/>
+                      <a:round/>
+                      <a:headEnd type="none" w="med" len="med"/>
+                      <a:tailEnd type="none" w="med" len="med"/>
+                    </a:lnB>
+                    <a:solidFill>
+                      <a:srgbClr val="D9E3EE"/>
+                    </a:solidFill>
+                  </a:tcPr>
+                </a:tc>
+                <a:tc>
+                  <a:txBody>
+                    <a:bodyPr/>
+                    <a:lstStyle/>
+                    <a:p>
+                      <a:pPr algn="ctr" indent="0" marL="0">
+                        <a:buNone/>
+                      </a:pPr>
+                      <a:r>
+                        <a:rPr lang="en-US" sz="1500" b="1" dirty="0">
+                          <a:solidFill>
+                            <a:srgbClr val="1F4E79"/>
+                          </a:solidFill>
+                        </a:rPr>
+                        <a:t>0.4278</a:t>
+                      </a:r>
+                      <a:endParaRPr lang="en-US" sz="1500" dirty="0"/>
+                    </a:p>
+                  </a:txBody>
+                  <a:tcPr marL="91440" marR="91440" marT="45720" marB="45720" anchor="ctr">
+                    <a:lnL w="9525" cap="flat" cmpd="sng" algn="ctr">
+                      <a:solidFill>
+                        <a:srgbClr val="E2E6EB"/>
+                      </a:solidFill>
+                      <a:prstDash val="solid"/>
+                      <a:round/>
+                      <a:headEnd type="none" w="med" len="med"/>
+                      <a:tailEnd type="none" w="med" len="med"/>
+                    </a:lnL>
+                    <a:lnR w="9525" cap="flat" cmpd="sng" algn="ctr">
+                      <a:solidFill>
+                        <a:srgbClr val="E2E6EB"/>
+                      </a:solidFill>
+                      <a:prstDash val="solid"/>
+                      <a:round/>
+                      <a:headEnd type="none" w="med" len="med"/>
+                      <a:tailEnd type="none" w="med" len="med"/>
+                    </a:lnR>
+                    <a:lnT w="9525" cap="flat" cmpd="sng" algn="ctr">
+                      <a:solidFill>
+                        <a:srgbClr val="E2E6EB"/>
+                      </a:solidFill>
+                      <a:prstDash val="solid"/>
+                      <a:round/>
+                      <a:headEnd type="none" w="med" len="med"/>
+                      <a:tailEnd type="none" w="med" len="med"/>
+                    </a:lnT>
+                    <a:lnB w="9525" cap="flat" cmpd="sng" algn="ctr">
+                      <a:solidFill>
+                        <a:srgbClr val="E2E6EB"/>
+                      </a:solidFill>
+                      <a:prstDash val="solid"/>
+                      <a:round/>
+                      <a:headEnd type="none" w="med" len="med"/>
+                      <a:tailEnd type="none" w="med" len="med"/>
+                    </a:lnB>
+                    <a:solidFill>
+                      <a:srgbClr val="D9E3EE"/>
+                    </a:solidFill>
+                  </a:tcPr>
+                </a:tc>
+                <a:tc>
+                  <a:txBody>
+                    <a:bodyPr/>
+                    <a:lstStyle/>
+                    <a:p>
+                      <a:pPr algn="ctr" indent="0" marL="0">
+                        <a:buNone/>
+                      </a:pPr>
+                      <a:r>
+                        <a:rPr lang="en-US" sz="1500" b="1" dirty="0">
+                          <a:solidFill>
+                            <a:srgbClr val="1F4E79"/>
+                          </a:solidFill>
+                        </a:rPr>
+                        <a:t>0.863</a:t>
+                      </a:r>
+                      <a:endParaRPr lang="en-US" sz="1500" dirty="0"/>
+                    </a:p>
+                  </a:txBody>
+                  <a:tcPr marL="91440" marR="91440" marT="45720" marB="45720" anchor="ctr">
+                    <a:lnL w="9525" cap="flat" cmpd="sng" algn="ctr">
+                      <a:solidFill>
+                        <a:srgbClr val="E2E6EB"/>
+                      </a:solidFill>
+                      <a:prstDash val="solid"/>
+                      <a:round/>
+                      <a:headEnd type="none" w="med" len="med"/>
+                      <a:tailEnd type="none" w="med" len="med"/>
+                    </a:lnL>
+                    <a:lnR w="9525" cap="flat" cmpd="sng" algn="ctr">
+                      <a:solidFill>
+                        <a:srgbClr val="E2E6EB"/>
+                      </a:solidFill>
+                      <a:prstDash val="solid"/>
+                      <a:round/>
+                      <a:headEnd type="none" w="med" len="med"/>
+                      <a:tailEnd type="none" w="med" len="med"/>
+                    </a:lnR>
+                    <a:lnT w="9525" cap="flat" cmpd="sng" algn="ctr">
+                      <a:solidFill>
+                        <a:srgbClr val="E2E6EB"/>
+                      </a:solidFill>
+                      <a:prstDash val="solid"/>
+                      <a:round/>
+                      <a:headEnd type="none" w="med" len="med"/>
+                      <a:tailEnd type="none" w="med" len="med"/>
+                    </a:lnT>
+                    <a:lnB w="9525" cap="flat" cmpd="sng" algn="ctr">
+                      <a:solidFill>
+                        <a:srgbClr val="E2E6EB"/>
+                      </a:solidFill>
+                      <a:prstDash val="solid"/>
+                      <a:round/>
+                      <a:headEnd type="none" w="med" len="med"/>
+                      <a:tailEnd type="none" w="med" len="med"/>
+                    </a:lnB>
+                    <a:solidFill>
+                      <a:srgbClr val="D9E3EE"/>
+                    </a:solidFill>
+                  </a:tcPr>
+                </a:tc>
+                <a:tc>
+                  <a:txBody>
+                    <a:bodyPr/>
+                    <a:lstStyle/>
+                    <a:p>
+                      <a:pPr algn="ctr" indent="0" marL="0">
+                        <a:buNone/>
+                      </a:pPr>
+                      <a:r>
+                        <a:rPr lang="en-US" sz="1500" b="1" dirty="0">
+                          <a:solidFill>
+                            <a:srgbClr val="1F4E79"/>
+                          </a:solidFill>
+                        </a:rPr>
+                        <a:t>13.1%</a:t>
+                      </a:r>
+                      <a:endParaRPr lang="en-US" sz="1500" dirty="0"/>
+                    </a:p>
+                  </a:txBody>
+                  <a:tcPr marL="91440" marR="91440" marT="45720" marB="45720" anchor="ctr">
+                    <a:lnL w="9525" cap="flat" cmpd="sng" algn="ctr">
+                      <a:solidFill>
+                        <a:srgbClr val="E2E6EB"/>
+                      </a:solidFill>
+                      <a:prstDash val="solid"/>
+                      <a:round/>
+                      <a:headEnd type="none" w="med" len="med"/>
+                      <a:tailEnd type="none" w="med" len="med"/>
+                    </a:lnL>
+                    <a:lnR w="9525" cap="flat" cmpd="sng" algn="ctr">
+                      <a:solidFill>
+                        <a:srgbClr val="E2E6EB"/>
+                      </a:solidFill>
+                      <a:prstDash val="solid"/>
+                      <a:round/>
+                      <a:headEnd type="none" w="med" len="med"/>
+                      <a:tailEnd type="none" w="med" len="med"/>
+                    </a:lnR>
+                    <a:lnT w="9525" cap="flat" cmpd="sng" algn="ctr">
+                      <a:solidFill>
+                        <a:srgbClr val="E2E6EB"/>
+                      </a:solidFill>
+                      <a:prstDash val="solid"/>
+                      <a:round/>
+                      <a:headEnd type="none" w="med" len="med"/>
+                      <a:tailEnd type="none" w="med" len="med"/>
+                    </a:lnT>
+                    <a:lnB w="9525" cap="flat" cmpd="sng" algn="ctr">
+                      <a:solidFill>
+                        <a:srgbClr val="E2E6EB"/>
+                      </a:solidFill>
+                      <a:prstDash val="solid"/>
+                      <a:round/>
+                      <a:headEnd type="none" w="med" len="med"/>
+                      <a:tailEnd type="none" w="med" len="med"/>
+                    </a:lnB>
+                    <a:solidFill>
+                      <a:srgbClr val="D9E3EE"/>
+                    </a:solidFill>
+                  </a:tcPr>
+                </a:tc>
+              </a:tr>
+              <a:tr h="411480">
                 <a:tc>
                   <a:txBody>
                     <a:bodyPr/>
@@ -6255,7 +6677,7 @@
                   </a:tcPr>
                 </a:tc>
               </a:tr>
-              <a:tr h="457200">
+              <a:tr h="411480">
                 <a:tc>
                   <a:txBody>
                     <a:bodyPr/>
@@ -6501,7 +6923,7 @@
                   </a:tcPr>
                 </a:tc>
               </a:tr>
-              <a:tr h="457200">
+              <a:tr h="411480">
                 <a:tc>
                   <a:txBody>
                     <a:bodyPr/>
@@ -6516,7 +6938,7 @@
                             <a:srgbClr val="1C2430"/>
                           </a:solidFill>
                         </a:rPr>
-                        <a:t>CatBoost (tuned) ★ new</a:t>
+                        <a:t>CatBoost (tuned)</a:t>
                       </a:r>
                       <a:endParaRPr lang="en-US" sz="1500" dirty="0"/>
                     </a:p>
@@ -6747,7 +7169,7 @@
                   </a:tcPr>
                 </a:tc>
               </a:tr>
-              <a:tr h="457200">
+              <a:tr h="411480">
                 <a:tc>
                   <a:txBody>
                     <a:bodyPr/>
@@ -6993,7 +7415,7 @@
                   </a:tcPr>
                 </a:tc>
               </a:tr>
-              <a:tr h="457200">
+              <a:tr h="411480">
                 <a:tc>
                   <a:txBody>
                     <a:bodyPr/>
@@ -7239,7 +7661,7 @@
                   </a:tcPr>
                 </a:tc>
               </a:tr>
-              <a:tr h="457200">
+              <a:tr h="411480">
                 <a:tc>
                   <a:txBody>
                     <a:bodyPr/>
@@ -7497,7 +7919,7 @@
         </p:nvSpPr>
         <p:spPr>
           <a:xfrm>
-            <a:off x="548640" y="5486400"/>
+            <a:off x="548640" y="5532120"/>
             <a:ext cx="7406640" cy="548640"/>
           </a:xfrm>
           <a:prstGeom prst="rect">
@@ -7519,7 +7941,7 @@
                   <a:schemeClr val="accent4"/>
                 </a:solidFill>
               </a:rPr>
-              <a:t>Ranked by cross-validated error (training data only). Tuning lifted R² from about 0.83 (defaults) to 0.86. Band classifier: 90.5% accuracy.</a:t>
+              <a:t>All models except NGBoost were taught. Ranked by cross-validated error (training data only). Tuning lifted R² from about 0.83 (defaults) to 0.86.</a:t>
             </a:r>
             <a:endParaRPr lang="en-US" sz="1200" dirty="0"/>
           </a:p>
@@ -7585,7 +8007,7 @@
                 <a:ea typeface="Cambria" pitchFamily="34" charset="-122"/>
                 <a:cs typeface="Cambria" pitchFamily="34" charset="-120"/>
               </a:rPr>
-              <a:t>★ New algorithm: CatBoost</a:t>
+              <a:t>★ New algorithm: NGBoost</a:t>
             </a:r>
             <a:endParaRPr lang="en-US" sz="1800" dirty="0"/>
           </a:p>
@@ -7643,7 +8065,7 @@
                   <a:schemeClr val="tx1"/>
                 </a:solidFill>
               </a:rPr>
-              <a:t>Handles the 160 area categories natively, without target leakage</a:t>
+              <a:t>Predicts a price distribution, not one number, giving an 80% price range</a:t>
             </a:r>
             <a:endParaRPr lang="en-US" sz="1400" dirty="0"/>
           </a:p>
@@ -7661,7 +8083,7 @@
                   <a:schemeClr val="tx1"/>
                 </a:solidFill>
               </a:rPr>
-              <a:t>R² 0.866 (tied best); best on unseen areas</a:t>
+              <a:t>3rd best on CV; ranges hold 82% of actual prices</a:t>
             </a:r>
             <a:endParaRPr lang="en-US" sz="1400" dirty="0"/>
           </a:p>
@@ -7758,7 +8180,7 @@
                   <a:schemeClr val="tx1"/>
                 </a:solidFill>
               </a:rPr>
-              <a:t>Combines RF + XGBoost + CatBoost</a:t>
+              <a:t>App: stacking price + NGBoost range</a:t>
             </a:r>
             <a:endParaRPr lang="en-US" sz="1400" dirty="0"/>
           </a:p>
@@ -8648,7 +9070,7 @@
                   <a:schemeClr val="accent2"/>
                 </a:solidFill>
               </a:rPr>
-              <a:t>Every price is explained: "Why this price?" (SHAP)</a:t>
+              <a:t>Every price has a likely range (NGBoost) and an explanation (SHAP)</a:t>
             </a:r>
             <a:endParaRPr lang="en-US" sz="1400" dirty="0"/>
           </a:p>
@@ -8774,7 +9196,7 @@
                   <a:schemeClr val="tx2"/>
                 </a:solidFill>
               </a:rPr>
-              <a:t>CI: 15 tests passing</a:t>
+              <a:t>CI: 17 tests passing</a:t>
             </a:r>
             <a:endParaRPr lang="en-US" sz="1500" dirty="0"/>
           </a:p>
@@ -9546,7 +9968,7 @@
                 <a:gridCol w="1737360"/>
                 <a:gridCol w="1463040"/>
               </a:tblGrid>
-              <a:tr h="457200">
+              <a:tr h="411480">
                 <a:tc>
                   <a:txBody>
                     <a:bodyPr/>
@@ -9914,7 +10336,7 @@
                   </a:tcPr>
                 </a:tc>
               </a:tr>
-              <a:tr h="457200">
+              <a:tr h="411480">
                 <a:tc>
                   <a:txBody>
                     <a:bodyPr/>
@@ -10264,7 +10686,7 @@
                   </a:tcPr>
                 </a:tc>
               </a:tr>
-              <a:tr h="457200">
+              <a:tr h="411480">
                 <a:tc>
                   <a:txBody>
                     <a:bodyPr/>
@@ -10614,7 +11036,357 @@
                   </a:tcPr>
                 </a:tc>
               </a:tr>
-              <a:tr h="457200">
+              <a:tr h="411480">
+                <a:tc>
+                  <a:txBody>
+                    <a:bodyPr/>
+                    <a:lstStyle/>
+                    <a:p>
+                      <a:pPr indent="0" marL="0">
+                        <a:buNone/>
+                      </a:pPr>
+                      <a:r>
+                        <a:rPr lang="en-US" sz="1400" dirty="0">
+                          <a:solidFill>
+                            <a:srgbClr val="1C2430"/>
+                          </a:solidFill>
+                        </a:rPr>
+                        <a:t>NGBoost (tuned) ★ new</a:t>
+                      </a:r>
+                      <a:endParaRPr lang="en-US" sz="1400" dirty="0"/>
+                    </a:p>
+                  </a:txBody>
+                  <a:tcPr marL="91440" marR="91440" marT="45720" marB="45720" anchor="ctr">
+                    <a:lnL w="9525" cap="flat" cmpd="sng" algn="ctr">
+                      <a:solidFill>
+                        <a:srgbClr val="E2E6EB"/>
+                      </a:solidFill>
+                      <a:prstDash val="solid"/>
+                      <a:round/>
+                      <a:headEnd type="none" w="med" len="med"/>
+                      <a:tailEnd type="none" w="med" len="med"/>
+                    </a:lnL>
+                    <a:lnR w="9525" cap="flat" cmpd="sng" algn="ctr">
+                      <a:solidFill>
+                        <a:srgbClr val="E2E6EB"/>
+                      </a:solidFill>
+                      <a:prstDash val="solid"/>
+                      <a:round/>
+                      <a:headEnd type="none" w="med" len="med"/>
+                      <a:tailEnd type="none" w="med" len="med"/>
+                    </a:lnR>
+                    <a:lnT w="9525" cap="flat" cmpd="sng" algn="ctr">
+                      <a:solidFill>
+                        <a:srgbClr val="E2E6EB"/>
+                      </a:solidFill>
+                      <a:prstDash val="solid"/>
+                      <a:round/>
+                      <a:headEnd type="none" w="med" len="med"/>
+                      <a:tailEnd type="none" w="med" len="med"/>
+                    </a:lnT>
+                    <a:lnB w="9525" cap="flat" cmpd="sng" algn="ctr">
+                      <a:solidFill>
+                        <a:srgbClr val="E2E6EB"/>
+                      </a:solidFill>
+                      <a:prstDash val="solid"/>
+                      <a:round/>
+                      <a:headEnd type="none" w="med" len="med"/>
+                      <a:tailEnd type="none" w="med" len="med"/>
+                    </a:lnB>
+                  </a:tcPr>
+                </a:tc>
+                <a:tc>
+                  <a:txBody>
+                    <a:bodyPr/>
+                    <a:lstStyle/>
+                    <a:p>
+                      <a:pPr indent="0" marL="0">
+                        <a:buNone/>
+                      </a:pPr>
+                      <a:r>
+                        <a:rPr lang="en-US" sz="1400" dirty="0">
+                          <a:solidFill>
+                            <a:srgbClr val="1C2430"/>
+                          </a:solidFill>
+                        </a:rPr>
+                        <a:t>0.4278</a:t>
+                      </a:r>
+                      <a:endParaRPr lang="en-US" sz="1400" dirty="0"/>
+                    </a:p>
+                  </a:txBody>
+                  <a:tcPr marL="91440" marR="91440" marT="45720" marB="45720" anchor="ctr">
+                    <a:lnL w="9525" cap="flat" cmpd="sng" algn="ctr">
+                      <a:solidFill>
+                        <a:srgbClr val="E2E6EB"/>
+                      </a:solidFill>
+                      <a:prstDash val="solid"/>
+                      <a:round/>
+                      <a:headEnd type="none" w="med" len="med"/>
+                      <a:tailEnd type="none" w="med" len="med"/>
+                    </a:lnL>
+                    <a:lnR w="9525" cap="flat" cmpd="sng" algn="ctr">
+                      <a:solidFill>
+                        <a:srgbClr val="E2E6EB"/>
+                      </a:solidFill>
+                      <a:prstDash val="solid"/>
+                      <a:round/>
+                      <a:headEnd type="none" w="med" len="med"/>
+                      <a:tailEnd type="none" w="med" len="med"/>
+                    </a:lnR>
+                    <a:lnT w="9525" cap="flat" cmpd="sng" algn="ctr">
+                      <a:solidFill>
+                        <a:srgbClr val="E2E6EB"/>
+                      </a:solidFill>
+                      <a:prstDash val="solid"/>
+                      <a:round/>
+                      <a:headEnd type="none" w="med" len="med"/>
+                      <a:tailEnd type="none" w="med" len="med"/>
+                    </a:lnT>
+                    <a:lnB w="9525" cap="flat" cmpd="sng" algn="ctr">
+                      <a:solidFill>
+                        <a:srgbClr val="E2E6EB"/>
+                      </a:solidFill>
+                      <a:prstDash val="solid"/>
+                      <a:round/>
+                      <a:headEnd type="none" w="med" len="med"/>
+                      <a:tailEnd type="none" w="med" len="med"/>
+                    </a:lnB>
+                  </a:tcPr>
+                </a:tc>
+                <a:tc>
+                  <a:txBody>
+                    <a:bodyPr/>
+                    <a:lstStyle/>
+                    <a:p>
+                      <a:pPr indent="0" marL="0">
+                        <a:buNone/>
+                      </a:pPr>
+                      <a:r>
+                        <a:rPr lang="en-US" sz="1400" dirty="0">
+                          <a:solidFill>
+                            <a:srgbClr val="1C2430"/>
+                          </a:solidFill>
+                        </a:rPr>
+                        <a:t>0.3714</a:t>
+                      </a:r>
+                      <a:endParaRPr lang="en-US" sz="1400" dirty="0"/>
+                    </a:p>
+                  </a:txBody>
+                  <a:tcPr marL="91440" marR="91440" marT="45720" marB="45720" anchor="ctr">
+                    <a:lnL w="9525" cap="flat" cmpd="sng" algn="ctr">
+                      <a:solidFill>
+                        <a:srgbClr val="E2E6EB"/>
+                      </a:solidFill>
+                      <a:prstDash val="solid"/>
+                      <a:round/>
+                      <a:headEnd type="none" w="med" len="med"/>
+                      <a:tailEnd type="none" w="med" len="med"/>
+                    </a:lnL>
+                    <a:lnR w="9525" cap="flat" cmpd="sng" algn="ctr">
+                      <a:solidFill>
+                        <a:srgbClr val="E2E6EB"/>
+                      </a:solidFill>
+                      <a:prstDash val="solid"/>
+                      <a:round/>
+                      <a:headEnd type="none" w="med" len="med"/>
+                      <a:tailEnd type="none" w="med" len="med"/>
+                    </a:lnR>
+                    <a:lnT w="9525" cap="flat" cmpd="sng" algn="ctr">
+                      <a:solidFill>
+                        <a:srgbClr val="E2E6EB"/>
+                      </a:solidFill>
+                      <a:prstDash val="solid"/>
+                      <a:round/>
+                      <a:headEnd type="none" w="med" len="med"/>
+                      <a:tailEnd type="none" w="med" len="med"/>
+                    </a:lnT>
+                    <a:lnB w="9525" cap="flat" cmpd="sng" algn="ctr">
+                      <a:solidFill>
+                        <a:srgbClr val="E2E6EB"/>
+                      </a:solidFill>
+                      <a:prstDash val="solid"/>
+                      <a:round/>
+                      <a:headEnd type="none" w="med" len="med"/>
+                      <a:tailEnd type="none" w="med" len="med"/>
+                    </a:lnB>
+                  </a:tcPr>
+                </a:tc>
+                <a:tc>
+                  <a:txBody>
+                    <a:bodyPr/>
+                    <a:lstStyle/>
+                    <a:p>
+                      <a:pPr indent="0" marL="0">
+                        <a:buNone/>
+                      </a:pPr>
+                      <a:r>
+                        <a:rPr lang="en-US" sz="1400" dirty="0">
+                          <a:solidFill>
+                            <a:srgbClr val="1C2430"/>
+                          </a:solidFill>
+                        </a:rPr>
+                        <a:t>0.863</a:t>
+                      </a:r>
+                      <a:endParaRPr lang="en-US" sz="1400" dirty="0"/>
+                    </a:p>
+                  </a:txBody>
+                  <a:tcPr marL="91440" marR="91440" marT="45720" marB="45720" anchor="ctr">
+                    <a:lnL w="9525" cap="flat" cmpd="sng" algn="ctr">
+                      <a:solidFill>
+                        <a:srgbClr val="E2E6EB"/>
+                      </a:solidFill>
+                      <a:prstDash val="solid"/>
+                      <a:round/>
+                      <a:headEnd type="none" w="med" len="med"/>
+                      <a:tailEnd type="none" w="med" len="med"/>
+                    </a:lnL>
+                    <a:lnR w="9525" cap="flat" cmpd="sng" algn="ctr">
+                      <a:solidFill>
+                        <a:srgbClr val="E2E6EB"/>
+                      </a:solidFill>
+                      <a:prstDash val="solid"/>
+                      <a:round/>
+                      <a:headEnd type="none" w="med" len="med"/>
+                      <a:tailEnd type="none" w="med" len="med"/>
+                    </a:lnR>
+                    <a:lnT w="9525" cap="flat" cmpd="sng" algn="ctr">
+                      <a:solidFill>
+                        <a:srgbClr val="E2E6EB"/>
+                      </a:solidFill>
+                      <a:prstDash val="solid"/>
+                      <a:round/>
+                      <a:headEnd type="none" w="med" len="med"/>
+                      <a:tailEnd type="none" w="med" len="med"/>
+                    </a:lnT>
+                    <a:lnB w="9525" cap="flat" cmpd="sng" algn="ctr">
+                      <a:solidFill>
+                        <a:srgbClr val="E2E6EB"/>
+                      </a:solidFill>
+                      <a:prstDash val="solid"/>
+                      <a:round/>
+                      <a:headEnd type="none" w="med" len="med"/>
+                      <a:tailEnd type="none" w="med" len="med"/>
+                    </a:lnB>
+                  </a:tcPr>
+                </a:tc>
+                <a:tc>
+                  <a:txBody>
+                    <a:bodyPr/>
+                    <a:lstStyle/>
+                    <a:p>
+                      <a:pPr indent="0" marL="0">
+                        <a:buNone/>
+                      </a:pPr>
+                      <a:r>
+                        <a:rPr lang="en-US" sz="1400" dirty="0">
+                          <a:solidFill>
+                            <a:srgbClr val="1C2430"/>
+                          </a:solidFill>
+                        </a:rPr>
+                        <a:t>572,292</a:t>
+                      </a:r>
+                      <a:endParaRPr lang="en-US" sz="1400" dirty="0"/>
+                    </a:p>
+                  </a:txBody>
+                  <a:tcPr marL="91440" marR="91440" marT="45720" marB="45720" anchor="ctr">
+                    <a:lnL w="9525" cap="flat" cmpd="sng" algn="ctr">
+                      <a:solidFill>
+                        <a:srgbClr val="E2E6EB"/>
+                      </a:solidFill>
+                      <a:prstDash val="solid"/>
+                      <a:round/>
+                      <a:headEnd type="none" w="med" len="med"/>
+                      <a:tailEnd type="none" w="med" len="med"/>
+                    </a:lnL>
+                    <a:lnR w="9525" cap="flat" cmpd="sng" algn="ctr">
+                      <a:solidFill>
+                        <a:srgbClr val="E2E6EB"/>
+                      </a:solidFill>
+                      <a:prstDash val="solid"/>
+                      <a:round/>
+                      <a:headEnd type="none" w="med" len="med"/>
+                      <a:tailEnd type="none" w="med" len="med"/>
+                    </a:lnR>
+                    <a:lnT w="9525" cap="flat" cmpd="sng" algn="ctr">
+                      <a:solidFill>
+                        <a:srgbClr val="E2E6EB"/>
+                      </a:solidFill>
+                      <a:prstDash val="solid"/>
+                      <a:round/>
+                      <a:headEnd type="none" w="med" len="med"/>
+                      <a:tailEnd type="none" w="med" len="med"/>
+                    </a:lnT>
+                    <a:lnB w="9525" cap="flat" cmpd="sng" algn="ctr">
+                      <a:solidFill>
+                        <a:srgbClr val="E2E6EB"/>
+                      </a:solidFill>
+                      <a:prstDash val="solid"/>
+                      <a:round/>
+                      <a:headEnd type="none" w="med" len="med"/>
+                      <a:tailEnd type="none" w="med" len="med"/>
+                    </a:lnB>
+                  </a:tcPr>
+                </a:tc>
+                <a:tc>
+                  <a:txBody>
+                    <a:bodyPr/>
+                    <a:lstStyle/>
+                    <a:p>
+                      <a:pPr indent="0" marL="0">
+                        <a:buNone/>
+                      </a:pPr>
+                      <a:r>
+                        <a:rPr lang="en-US" sz="1400" dirty="0">
+                          <a:solidFill>
+                            <a:srgbClr val="1C2430"/>
+                          </a:solidFill>
+                        </a:rPr>
+                        <a:t>13.1%</a:t>
+                      </a:r>
+                      <a:endParaRPr lang="en-US" sz="1400" dirty="0"/>
+                    </a:p>
+                  </a:txBody>
+                  <a:tcPr marL="91440" marR="91440" marT="45720" marB="45720" anchor="ctr">
+                    <a:lnL w="9525" cap="flat" cmpd="sng" algn="ctr">
+                      <a:solidFill>
+                        <a:srgbClr val="E2E6EB"/>
+                      </a:solidFill>
+                      <a:prstDash val="solid"/>
+                      <a:round/>
+                      <a:headEnd type="none" w="med" len="med"/>
+                      <a:tailEnd type="none" w="med" len="med"/>
+                    </a:lnL>
+                    <a:lnR w="9525" cap="flat" cmpd="sng" algn="ctr">
+                      <a:solidFill>
+                        <a:srgbClr val="E2E6EB"/>
+                      </a:solidFill>
+                      <a:prstDash val="solid"/>
+                      <a:round/>
+                      <a:headEnd type="none" w="med" len="med"/>
+                      <a:tailEnd type="none" w="med" len="med"/>
+                    </a:lnR>
+                    <a:lnT w="9525" cap="flat" cmpd="sng" algn="ctr">
+                      <a:solidFill>
+                        <a:srgbClr val="E2E6EB"/>
+                      </a:solidFill>
+                      <a:prstDash val="solid"/>
+                      <a:round/>
+                      <a:headEnd type="none" w="med" len="med"/>
+                      <a:tailEnd type="none" w="med" len="med"/>
+                    </a:lnT>
+                    <a:lnB w="9525" cap="flat" cmpd="sng" algn="ctr">
+                      <a:solidFill>
+                        <a:srgbClr val="E2E6EB"/>
+                      </a:solidFill>
+                      <a:prstDash val="solid"/>
+                      <a:round/>
+                      <a:headEnd type="none" w="med" len="med"/>
+                      <a:tailEnd type="none" w="med" len="med"/>
+                    </a:lnB>
+                  </a:tcPr>
+                </a:tc>
+              </a:tr>
+              <a:tr h="411480">
                 <a:tc>
                   <a:txBody>
                     <a:bodyPr/>
@@ -10964,7 +11736,7 @@
                   </a:tcPr>
                 </a:tc>
               </a:tr>
-              <a:tr h="457200">
+              <a:tr h="411480">
                 <a:tc>
                   <a:txBody>
                     <a:bodyPr/>
@@ -11314,7 +12086,7 @@
                   </a:tcPr>
                 </a:tc>
               </a:tr>
-              <a:tr h="457200">
+              <a:tr h="411480">
                 <a:tc>
                   <a:txBody>
                     <a:bodyPr/>
@@ -11664,7 +12436,357 @@
                   </a:tcPr>
                 </a:tc>
               </a:tr>
-              <a:tr h="457200">
+              <a:tr h="411480">
+                <a:tc>
+                  <a:txBody>
+                    <a:bodyPr/>
+                    <a:lstStyle/>
+                    <a:p>
+                      <a:pPr indent="0" marL="0">
+                        <a:buNone/>
+                      </a:pPr>
+                      <a:r>
+                        <a:rPr lang="en-US" sz="1400" dirty="0">
+                          <a:solidFill>
+                            <a:srgbClr val="1C2430"/>
+                          </a:solidFill>
+                        </a:rPr>
+                        <a:t>NGBoost (default)</a:t>
+                      </a:r>
+                      <a:endParaRPr lang="en-US" sz="1400" dirty="0"/>
+                    </a:p>
+                  </a:txBody>
+                  <a:tcPr marL="91440" marR="91440" marT="45720" marB="45720" anchor="ctr">
+                    <a:lnL w="9525" cap="flat" cmpd="sng" algn="ctr">
+                      <a:solidFill>
+                        <a:srgbClr val="E2E6EB"/>
+                      </a:solidFill>
+                      <a:prstDash val="solid"/>
+                      <a:round/>
+                      <a:headEnd type="none" w="med" len="med"/>
+                      <a:tailEnd type="none" w="med" len="med"/>
+                    </a:lnL>
+                    <a:lnR w="9525" cap="flat" cmpd="sng" algn="ctr">
+                      <a:solidFill>
+                        <a:srgbClr val="E2E6EB"/>
+                      </a:solidFill>
+                      <a:prstDash val="solid"/>
+                      <a:round/>
+                      <a:headEnd type="none" w="med" len="med"/>
+                      <a:tailEnd type="none" w="med" len="med"/>
+                    </a:lnR>
+                    <a:lnT w="9525" cap="flat" cmpd="sng" algn="ctr">
+                      <a:solidFill>
+                        <a:srgbClr val="E2E6EB"/>
+                      </a:solidFill>
+                      <a:prstDash val="solid"/>
+                      <a:round/>
+                      <a:headEnd type="none" w="med" len="med"/>
+                      <a:tailEnd type="none" w="med" len="med"/>
+                    </a:lnT>
+                    <a:lnB w="9525" cap="flat" cmpd="sng" algn="ctr">
+                      <a:solidFill>
+                        <a:srgbClr val="E2E6EB"/>
+                      </a:solidFill>
+                      <a:prstDash val="solid"/>
+                      <a:round/>
+                      <a:headEnd type="none" w="med" len="med"/>
+                      <a:tailEnd type="none" w="med" len="med"/>
+                    </a:lnB>
+                  </a:tcPr>
+                </a:tc>
+                <a:tc>
+                  <a:txBody>
+                    <a:bodyPr/>
+                    <a:lstStyle/>
+                    <a:p>
+                      <a:pPr indent="0" marL="0">
+                        <a:buNone/>
+                      </a:pPr>
+                      <a:r>
+                        <a:rPr lang="en-US" sz="1400" dirty="0">
+                          <a:solidFill>
+                            <a:srgbClr val="1C2430"/>
+                          </a:solidFill>
+                        </a:rPr>
+                        <a:t>0.4372</a:t>
+                      </a:r>
+                      <a:endParaRPr lang="en-US" sz="1400" dirty="0"/>
+                    </a:p>
+                  </a:txBody>
+                  <a:tcPr marL="91440" marR="91440" marT="45720" marB="45720" anchor="ctr">
+                    <a:lnL w="9525" cap="flat" cmpd="sng" algn="ctr">
+                      <a:solidFill>
+                        <a:srgbClr val="E2E6EB"/>
+                      </a:solidFill>
+                      <a:prstDash val="solid"/>
+                      <a:round/>
+                      <a:headEnd type="none" w="med" len="med"/>
+                      <a:tailEnd type="none" w="med" len="med"/>
+                    </a:lnL>
+                    <a:lnR w="9525" cap="flat" cmpd="sng" algn="ctr">
+                      <a:solidFill>
+                        <a:srgbClr val="E2E6EB"/>
+                      </a:solidFill>
+                      <a:prstDash val="solid"/>
+                      <a:round/>
+                      <a:headEnd type="none" w="med" len="med"/>
+                      <a:tailEnd type="none" w="med" len="med"/>
+                    </a:lnR>
+                    <a:lnT w="9525" cap="flat" cmpd="sng" algn="ctr">
+                      <a:solidFill>
+                        <a:srgbClr val="E2E6EB"/>
+                      </a:solidFill>
+                      <a:prstDash val="solid"/>
+                      <a:round/>
+                      <a:headEnd type="none" w="med" len="med"/>
+                      <a:tailEnd type="none" w="med" len="med"/>
+                    </a:lnT>
+                    <a:lnB w="9525" cap="flat" cmpd="sng" algn="ctr">
+                      <a:solidFill>
+                        <a:srgbClr val="E2E6EB"/>
+                      </a:solidFill>
+                      <a:prstDash val="solid"/>
+                      <a:round/>
+                      <a:headEnd type="none" w="med" len="med"/>
+                      <a:tailEnd type="none" w="med" len="med"/>
+                    </a:lnB>
+                  </a:tcPr>
+                </a:tc>
+                <a:tc>
+                  <a:txBody>
+                    <a:bodyPr/>
+                    <a:lstStyle/>
+                    <a:p>
+                      <a:pPr indent="0" marL="0">
+                        <a:buNone/>
+                      </a:pPr>
+                      <a:r>
+                        <a:rPr lang="en-US" sz="1400" dirty="0">
+                          <a:solidFill>
+                            <a:srgbClr val="1C2430"/>
+                          </a:solidFill>
+                        </a:rPr>
+                        <a:t>0.3921</a:t>
+                      </a:r>
+                      <a:endParaRPr lang="en-US" sz="1400" dirty="0"/>
+                    </a:p>
+                  </a:txBody>
+                  <a:tcPr marL="91440" marR="91440" marT="45720" marB="45720" anchor="ctr">
+                    <a:lnL w="9525" cap="flat" cmpd="sng" algn="ctr">
+                      <a:solidFill>
+                        <a:srgbClr val="E2E6EB"/>
+                      </a:solidFill>
+                      <a:prstDash val="solid"/>
+                      <a:round/>
+                      <a:headEnd type="none" w="med" len="med"/>
+                      <a:tailEnd type="none" w="med" len="med"/>
+                    </a:lnL>
+                    <a:lnR w="9525" cap="flat" cmpd="sng" algn="ctr">
+                      <a:solidFill>
+                        <a:srgbClr val="E2E6EB"/>
+                      </a:solidFill>
+                      <a:prstDash val="solid"/>
+                      <a:round/>
+                      <a:headEnd type="none" w="med" len="med"/>
+                      <a:tailEnd type="none" w="med" len="med"/>
+                    </a:lnR>
+                    <a:lnT w="9525" cap="flat" cmpd="sng" algn="ctr">
+                      <a:solidFill>
+                        <a:srgbClr val="E2E6EB"/>
+                      </a:solidFill>
+                      <a:prstDash val="solid"/>
+                      <a:round/>
+                      <a:headEnd type="none" w="med" len="med"/>
+                      <a:tailEnd type="none" w="med" len="med"/>
+                    </a:lnT>
+                    <a:lnB w="9525" cap="flat" cmpd="sng" algn="ctr">
+                      <a:solidFill>
+                        <a:srgbClr val="E2E6EB"/>
+                      </a:solidFill>
+                      <a:prstDash val="solid"/>
+                      <a:round/>
+                      <a:headEnd type="none" w="med" len="med"/>
+                      <a:tailEnd type="none" w="med" len="med"/>
+                    </a:lnB>
+                  </a:tcPr>
+                </a:tc>
+                <a:tc>
+                  <a:txBody>
+                    <a:bodyPr/>
+                    <a:lstStyle/>
+                    <a:p>
+                      <a:pPr indent="0" marL="0">
+                        <a:buNone/>
+                      </a:pPr>
+                      <a:r>
+                        <a:rPr lang="en-US" sz="1400" dirty="0">
+                          <a:solidFill>
+                            <a:srgbClr val="1C2430"/>
+                          </a:solidFill>
+                        </a:rPr>
+                        <a:t>0.848</a:t>
+                      </a:r>
+                      <a:endParaRPr lang="en-US" sz="1400" dirty="0"/>
+                    </a:p>
+                  </a:txBody>
+                  <a:tcPr marL="91440" marR="91440" marT="45720" marB="45720" anchor="ctr">
+                    <a:lnL w="9525" cap="flat" cmpd="sng" algn="ctr">
+                      <a:solidFill>
+                        <a:srgbClr val="E2E6EB"/>
+                      </a:solidFill>
+                      <a:prstDash val="solid"/>
+                      <a:round/>
+                      <a:headEnd type="none" w="med" len="med"/>
+                      <a:tailEnd type="none" w="med" len="med"/>
+                    </a:lnL>
+                    <a:lnR w="9525" cap="flat" cmpd="sng" algn="ctr">
+                      <a:solidFill>
+                        <a:srgbClr val="E2E6EB"/>
+                      </a:solidFill>
+                      <a:prstDash val="solid"/>
+                      <a:round/>
+                      <a:headEnd type="none" w="med" len="med"/>
+                      <a:tailEnd type="none" w="med" len="med"/>
+                    </a:lnR>
+                    <a:lnT w="9525" cap="flat" cmpd="sng" algn="ctr">
+                      <a:solidFill>
+                        <a:srgbClr val="E2E6EB"/>
+                      </a:solidFill>
+                      <a:prstDash val="solid"/>
+                      <a:round/>
+                      <a:headEnd type="none" w="med" len="med"/>
+                      <a:tailEnd type="none" w="med" len="med"/>
+                    </a:lnT>
+                    <a:lnB w="9525" cap="flat" cmpd="sng" algn="ctr">
+                      <a:solidFill>
+                        <a:srgbClr val="E2E6EB"/>
+                      </a:solidFill>
+                      <a:prstDash val="solid"/>
+                      <a:round/>
+                      <a:headEnd type="none" w="med" len="med"/>
+                      <a:tailEnd type="none" w="med" len="med"/>
+                    </a:lnB>
+                  </a:tcPr>
+                </a:tc>
+                <a:tc>
+                  <a:txBody>
+                    <a:bodyPr/>
+                    <a:lstStyle/>
+                    <a:p>
+                      <a:pPr indent="0" marL="0">
+                        <a:buNone/>
+                      </a:pPr>
+                      <a:r>
+                        <a:rPr lang="en-US" sz="1400" dirty="0">
+                          <a:solidFill>
+                            <a:srgbClr val="1C2430"/>
+                          </a:solidFill>
+                        </a:rPr>
+                        <a:t>596,068</a:t>
+                      </a:r>
+                      <a:endParaRPr lang="en-US" sz="1400" dirty="0"/>
+                    </a:p>
+                  </a:txBody>
+                  <a:tcPr marL="91440" marR="91440" marT="45720" marB="45720" anchor="ctr">
+                    <a:lnL w="9525" cap="flat" cmpd="sng" algn="ctr">
+                      <a:solidFill>
+                        <a:srgbClr val="E2E6EB"/>
+                      </a:solidFill>
+                      <a:prstDash val="solid"/>
+                      <a:round/>
+                      <a:headEnd type="none" w="med" len="med"/>
+                      <a:tailEnd type="none" w="med" len="med"/>
+                    </a:lnL>
+                    <a:lnR w="9525" cap="flat" cmpd="sng" algn="ctr">
+                      <a:solidFill>
+                        <a:srgbClr val="E2E6EB"/>
+                      </a:solidFill>
+                      <a:prstDash val="solid"/>
+                      <a:round/>
+                      <a:headEnd type="none" w="med" len="med"/>
+                      <a:tailEnd type="none" w="med" len="med"/>
+                    </a:lnR>
+                    <a:lnT w="9525" cap="flat" cmpd="sng" algn="ctr">
+                      <a:solidFill>
+                        <a:srgbClr val="E2E6EB"/>
+                      </a:solidFill>
+                      <a:prstDash val="solid"/>
+                      <a:round/>
+                      <a:headEnd type="none" w="med" len="med"/>
+                      <a:tailEnd type="none" w="med" len="med"/>
+                    </a:lnT>
+                    <a:lnB w="9525" cap="flat" cmpd="sng" algn="ctr">
+                      <a:solidFill>
+                        <a:srgbClr val="E2E6EB"/>
+                      </a:solidFill>
+                      <a:prstDash val="solid"/>
+                      <a:round/>
+                      <a:headEnd type="none" w="med" len="med"/>
+                      <a:tailEnd type="none" w="med" len="med"/>
+                    </a:lnB>
+                  </a:tcPr>
+                </a:tc>
+                <a:tc>
+                  <a:txBody>
+                    <a:bodyPr/>
+                    <a:lstStyle/>
+                    <a:p>
+                      <a:pPr indent="0" marL="0">
+                        <a:buNone/>
+                      </a:pPr>
+                      <a:r>
+                        <a:rPr lang="en-US" sz="1400" dirty="0">
+                          <a:solidFill>
+                            <a:srgbClr val="1C2430"/>
+                          </a:solidFill>
+                        </a:rPr>
+                        <a:t>14.5%</a:t>
+                      </a:r>
+                      <a:endParaRPr lang="en-US" sz="1400" dirty="0"/>
+                    </a:p>
+                  </a:txBody>
+                  <a:tcPr marL="91440" marR="91440" marT="45720" marB="45720" anchor="ctr">
+                    <a:lnL w="9525" cap="flat" cmpd="sng" algn="ctr">
+                      <a:solidFill>
+                        <a:srgbClr val="E2E6EB"/>
+                      </a:solidFill>
+                      <a:prstDash val="solid"/>
+                      <a:round/>
+                      <a:headEnd type="none" w="med" len="med"/>
+                      <a:tailEnd type="none" w="med" len="med"/>
+                    </a:lnL>
+                    <a:lnR w="9525" cap="flat" cmpd="sng" algn="ctr">
+                      <a:solidFill>
+                        <a:srgbClr val="E2E6EB"/>
+                      </a:solidFill>
+                      <a:prstDash val="solid"/>
+                      <a:round/>
+                      <a:headEnd type="none" w="med" len="med"/>
+                      <a:tailEnd type="none" w="med" len="med"/>
+                    </a:lnR>
+                    <a:lnT w="9525" cap="flat" cmpd="sng" algn="ctr">
+                      <a:solidFill>
+                        <a:srgbClr val="E2E6EB"/>
+                      </a:solidFill>
+                      <a:prstDash val="solid"/>
+                      <a:round/>
+                      <a:headEnd type="none" w="med" len="med"/>
+                      <a:tailEnd type="none" w="med" len="med"/>
+                    </a:lnT>
+                    <a:lnB w="9525" cap="flat" cmpd="sng" algn="ctr">
+                      <a:solidFill>
+                        <a:srgbClr val="E2E6EB"/>
+                      </a:solidFill>
+                      <a:prstDash val="solid"/>
+                      <a:round/>
+                      <a:headEnd type="none" w="med" len="med"/>
+                      <a:tailEnd type="none" w="med" len="med"/>
+                    </a:lnB>
+                  </a:tcPr>
+                </a:tc>
+              </a:tr>
+              <a:tr h="411480">
                 <a:tc>
                   <a:txBody>
                     <a:bodyPr/>
@@ -12014,7 +13136,7 @@
                   </a:tcPr>
                 </a:tc>
               </a:tr>
-              <a:tr h="457200">
+              <a:tr h="411480">
                 <a:tc>
                   <a:txBody>
                     <a:bodyPr/>
@@ -12364,7 +13486,7 @@
                   </a:tcPr>
                 </a:tc>
               </a:tr>
-              <a:tr h="457200">
+              <a:tr h="411480">
                 <a:tc>
                   <a:txBody>
                     <a:bodyPr/>

</xml_diff>